<commit_message>
docs: update Space_Monitor.pptx deck
Co-Authored-By: Claude Opus 4.7 (1M context) <noreply@anthropic.com>
</commit_message>
<xml_diff>
--- a/Space_Monitor.pptx
+++ b/Space_Monitor.pptx
@@ -5434,7 +5434,7 @@
         <p:spPr>
           <a:xfrm>
             <a:off x="952468" y="3199783"/>
-            <a:ext cx="8509501" cy="741468"/>
+            <a:ext cx="8509501" cy="1093152"/>
           </a:xfrm>
           <a:prstGeom prst="rect">
             <a:avLst/>
@@ -5463,7 +5463,7 @@
                 <a:ea typeface="-apple-system" pitchFamily="34" charset="-122"/>
                 <a:cs typeface="-apple-system" pitchFamily="34" charset="-120"/>
               </a:rPr>
-              <a:t>Bubble size = partnership count. Color depth = average partnership strength under the workbook's scoring rubric.</a:t>
+              <a:t>Every bilateral and multilateral partnership in the binder, plotted at its host country. Bubble size scales with partnership count; color encodes both parties in the pair.</a:t>
             </a:r>
             <a:endParaRPr lang="en-US" sz="1950" dirty="0"/>
           </a:p>
@@ -5477,8 +5477,8 @@
         </p:nvSpPr>
         <p:spPr>
           <a:xfrm>
-            <a:off x="952468" y="4169782"/>
-            <a:ext cx="16383062" cy="5355227"/>
+            <a:off x="952468" y="4521465"/>
+            <a:ext cx="16383062" cy="5003543"/>
           </a:xfrm>
           <a:prstGeom prst="rect">
             <a:avLst/>
@@ -5503,17 +5503,14 @@
           <p:nvPr/>
         </p:nvPicPr>
         <p:blipFill>
-          <a:blip r:embed="rId1">
-            <a:alphaModFix amt="55000"/>
-          </a:blip>
-          <a:stretch>
-            <a:fillRect/>
-          </a:stretch>
+          <a:blip r:embed="rId1"/>
+          <a:srcRect l="0" r="0" t="0" b="0"/>
+          <a:stretch/>
         </p:blipFill>
         <p:spPr>
           <a:xfrm>
-            <a:off x="8572540" y="5298092"/>
-            <a:ext cx="1142919" cy="1142919"/>
+            <a:off x="959394" y="4528391"/>
+            <a:ext cx="16369211" cy="4989692"/>
           </a:xfrm>
           <a:prstGeom prst="rect">
             <a:avLst/>
@@ -5522,81 +5519,22 @@
       </p:pic>
       <p:sp>
         <p:nvSpPr>
-          <p:cNvPr id="10" name="Text 7"/>
-          <p:cNvSpPr/>
-          <p:nvPr/>
-        </p:nvSpPr>
-        <p:spPr>
-          <a:xfrm>
-            <a:off x="5914207" y="6707641"/>
-            <a:ext cx="6459476" cy="769603"/>
-          </a:xfrm>
-          <a:prstGeom prst="rect">
-            <a:avLst/>
-          </a:prstGeom>
-          <a:noFill/>
-          <a:ln/>
-        </p:spPr>
-        <p:txBody>
-          <a:bodyPr wrap="square" lIns="25400" tIns="25400" rIns="25400" bIns="25400" rtlCol="0" anchor="t">
-            <a:normAutofit/>
-          </a:bodyPr>
-          <a:lstStyle/>
-          <a:p>
-            <a:pPr algn="ctr" indent="0" marL="0">
-              <a:lnSpc>
-                <a:spcPct val="160000"/>
-              </a:lnSpc>
-              <a:buNone/>
-            </a:pPr>
-            <a:r>
-              <a:rPr lang="en-US" sz="1800" spc="108" kern="0" dirty="0">
-                <a:solidFill>
-                  <a:srgbClr val="6B6555"/>
-                </a:solidFill>
-                <a:latin typeface="Arial" pitchFamily="34" charset="0"/>
-                <a:ea typeface="Arial" pitchFamily="34" charset="-122"/>
-                <a:cs typeface="Arial" pitchFamily="34" charset="-120"/>
-              </a:rPr>
-              <a:t>[ folium world map screenshot ] </a:t>
-            </a:r>
-            <a:pPr algn="ctr" indent="0" marL="0">
-              <a:lnSpc>
-                <a:spcPct val="160000"/>
-              </a:lnSpc>
-              <a:buNone/>
-            </a:pPr>
-            <a:r>
-              <a:rPr lang="en-US" sz="1500" spc="108" kern="0" dirty="0">
-                <a:solidFill>
-                  <a:srgbClr val="C8BEA9"/>
-                </a:solidFill>
-                <a:latin typeface="Arial" pitchFamily="34" charset="0"/>
-                <a:ea typeface="Arial" pitchFamily="34" charset="-122"/>
-                <a:cs typeface="Arial" pitchFamily="34" charset="-120"/>
-              </a:rPr>
-              <a:t>— drop in once the dashboard is hosted publicly —</a:t>
-            </a:r>
-            <a:endParaRPr lang="en-US" sz="1800" dirty="0"/>
-          </a:p>
-        </p:txBody>
-      </p:sp>
-      <p:sp>
-        <p:nvSpPr>
-          <p:cNvPr id="11" name="Shape 8"/>
-          <p:cNvSpPr/>
-          <p:nvPr/>
-        </p:nvSpPr>
-        <p:spPr>
-          <a:xfrm>
-            <a:off x="6249695" y="7820044"/>
-            <a:ext cx="5788501" cy="576545"/>
+          <p:cNvPr id="10" name="Shape 7"/>
+          <p:cNvSpPr/>
+          <p:nvPr/>
+        </p:nvSpPr>
+        <p:spPr>
+          <a:xfrm>
+            <a:off x="1187934" y="8770132"/>
+            <a:ext cx="7449208" cy="519410"/>
           </a:xfrm>
           <a:prstGeom prst="rect">
             <a:avLst/>
           </a:prstGeom>
           <a:solidFill>
-            <a:srgbClr val="F4EFE6"/>
+            <a:srgbClr val="F4EFE6">
+              <a:alpha val="96000"/>
+            </a:srgbClr>
           </a:solidFill>
           <a:ln w="6925">
             <a:solidFill>
@@ -5608,14 +5546,55 @@
       </p:sp>
       <p:sp>
         <p:nvSpPr>
+          <p:cNvPr id="11" name="Text 8"/>
+          <p:cNvSpPr/>
+          <p:nvPr/>
+        </p:nvSpPr>
+        <p:spPr>
+          <a:xfrm>
+            <a:off x="1385310" y="8929418"/>
+            <a:ext cx="2403590" cy="238939"/>
+          </a:xfrm>
+          <a:prstGeom prst="rect">
+            <a:avLst/>
+          </a:prstGeom>
+          <a:noFill/>
+          <a:ln/>
+        </p:spPr>
+        <p:txBody>
+          <a:bodyPr wrap="square" lIns="25400" tIns="25400" rIns="25400" bIns="25400" rtlCol="0" anchor="t">
+            <a:normAutofit/>
+          </a:bodyPr>
+          <a:lstStyle/>
+          <a:p>
+            <a:pPr algn="l" indent="0" marL="0">
+              <a:buNone/>
+            </a:pPr>
+            <a:r>
+              <a:rPr lang="en-US" sz="1200" dirty="0">
+                <a:solidFill>
+                  <a:srgbClr val="1B2738"/>
+                </a:solidFill>
+                <a:latin typeface="Arial" pitchFamily="34" charset="0"/>
+                <a:ea typeface="Arial" pitchFamily="34" charset="-122"/>
+                <a:cs typeface="Arial" pitchFamily="34" charset="-120"/>
+              </a:rPr>
+              <a:t>partnerships by location</a:t>
+            </a:r>
+            <a:endParaRPr lang="en-US" sz="1200" dirty="0"/>
+          </a:p>
+        </p:txBody>
+      </p:sp>
+      <p:sp>
+        <p:nvSpPr>
           <p:cNvPr id="12" name="Text 9"/>
           <p:cNvSpPr/>
           <p:nvPr/>
         </p:nvSpPr>
         <p:spPr>
           <a:xfrm>
-            <a:off x="6447070" y="7979330"/>
-            <a:ext cx="1839814" cy="296074"/>
+            <a:off x="3884106" y="8929418"/>
+            <a:ext cx="1763634" cy="238939"/>
           </a:xfrm>
           <a:prstGeom prst="rect">
             <a:avLst/>
@@ -5641,7 +5620,7 @@
                 <a:ea typeface="Arial" pitchFamily="34" charset="-122"/>
                 <a:cs typeface="Arial" pitchFamily="34" charset="-120"/>
               </a:rPr>
-              <a:t>more partnerships</a:t>
+              <a:t>strength weighted</a:t>
             </a:r>
             <a:endParaRPr lang="en-US" sz="1200" dirty="0"/>
           </a:p>
@@ -5655,50 +5634,7 @@
         </p:nvSpPr>
         <p:spPr>
           <a:xfrm>
-            <a:off x="8382090" y="8007898"/>
-            <a:ext cx="666704" cy="238939"/>
-          </a:xfrm>
-          <a:prstGeom prst="rect">
-            <a:avLst/>
-          </a:prstGeom>
-          <a:noFill/>
-          <a:ln/>
-        </p:spPr>
-        <p:txBody>
-          <a:bodyPr wrap="square" lIns="25400" tIns="25400" rIns="25400" bIns="25400" rtlCol="0" anchor="t">
-            <a:normAutofit/>
-          </a:bodyPr>
-          <a:lstStyle/>
-          <a:p>
-            <a:pPr algn="l" indent="0" marL="0">
-              <a:buNone/>
-            </a:pPr>
-            <a:r>
-              <a:rPr lang="en-US" sz="1200" dirty="0">
-                <a:solidFill>
-                  <a:srgbClr val="1B2738">
-                    <a:alpha val="50000"/>
-                  </a:srgbClr>
-                </a:solidFill>
-                <a:latin typeface="Arial" pitchFamily="34" charset="0"/>
-                <a:ea typeface="Arial" pitchFamily="34" charset="-122"/>
-                <a:cs typeface="Arial" pitchFamily="34" charset="-120"/>
-              </a:rPr>
-              <a:t>fewer</a:t>
-            </a:r>
-            <a:endParaRPr lang="en-US" sz="1200" dirty="0"/>
-          </a:p>
-        </p:txBody>
-      </p:sp>
-      <p:sp>
-        <p:nvSpPr>
-          <p:cNvPr id="14" name="Text 11"/>
-          <p:cNvSpPr/>
-          <p:nvPr/>
-        </p:nvSpPr>
-        <p:spPr>
-          <a:xfrm>
-            <a:off x="9372540" y="8007898"/>
+            <a:off x="5971486" y="8929418"/>
             <a:ext cx="2544480" cy="238939"/>
           </a:xfrm>
           <a:prstGeom prst="rect">

</xml_diff>